<commit_message>
docs: atualiza deck com regulação FINRA/CVM, acompanhamento e tabela water-filling
- Slide 2: adiciona bullet de conformidade FINRA e CVM (suitability)
- Slide 3: adiciona facilidade de execução e acompanhamento contínuo
- Slide 9: substitui ilustração de copos por tabela antes/depois do
  water-filling (6 categorias, compra por gap, peso depois em verde)

https://claude.ai/code/session_01GGCMt78sL4YUxx2jw4cc5n
</commit_message>
<xml_diff>
--- a/Modelo_de_Alocacao.pptx
+++ b/Modelo_de_Alocacao.pptx
@@ -5190,6 +5190,54 @@
               <a:t>–  Conhecimento preso na cabeça de poucas pessoas</a:t>
             </a:r>
           </a:p>
+          <a:p>
+            <a:pPr algn="l">
+              <a:spcAft>
+                <a:spcPts val="1000"/>
+              </a:spcAft>
+            </a:pPr>
+            <a:r>
+              <a:rPr sz="2000" b="1" i="0">
+                <a:solidFill>
+                  <a:srgbClr val="0B1F3A"/>
+                </a:solidFill>
+                <a:latin typeface="Calibri"/>
+              </a:rPr>
+              <a:t>A carteira deve estar em conformidade regulatória</a:t>
+            </a:r>
+          </a:p>
+          <a:p>
+            <a:pPr algn="l" lvl="1">
+              <a:spcAft>
+                <a:spcPts val="500"/>
+              </a:spcAft>
+            </a:pPr>
+            <a:r>
+              <a:rPr sz="1600" b="0" i="0">
+                <a:solidFill>
+                  <a:srgbClr val="3C4452"/>
+                </a:solidFill>
+                <a:latin typeface="Calibri"/>
+              </a:rPr>
+              <a:t>–  FINRA (EUA) e CVM (Brasil) impõem regras de suitability e adequação de produtos</a:t>
+            </a:r>
+          </a:p>
+          <a:p>
+            <a:pPr algn="l" lvl="1">
+              <a:spcAft>
+                <a:spcPts val="500"/>
+              </a:spcAft>
+            </a:pPr>
+            <a:r>
+              <a:rPr sz="1600" b="0" i="0">
+                <a:solidFill>
+                  <a:srgbClr val="3C4452"/>
+                </a:solidFill>
+                <a:latin typeface="Calibri"/>
+              </a:rPr>
+              <a:t>–  Qualquer recomendação precisa ser rastreável e justificável perante os reguladores</a:t>
+            </a:r>
+          </a:p>
         </p:txBody>
       </p:sp>
       <p:sp>
@@ -5569,6 +5617,86 @@
               <a:t>Uma ordem de compra pronta para o caixa que ele tem hoje</a:t>
             </a:r>
           </a:p>
+          <a:p>
+            <a:pPr algn="l">
+              <a:spcAft>
+                <a:spcPts val="1000"/>
+              </a:spcAft>
+            </a:pPr>
+            <a:r>
+              <a:rPr sz="2000" b="1" i="0">
+                <a:solidFill>
+                  <a:srgbClr val="0B1F3A"/>
+                </a:solidFill>
+                <a:latin typeface="Calibri"/>
+              </a:rPr>
+              <a:t>Facilidade de execução</a:t>
+            </a:r>
+          </a:p>
+          <a:p>
+            <a:pPr algn="l" lvl="1">
+              <a:spcAft>
+                <a:spcPts val="500"/>
+              </a:spcAft>
+            </a:pPr>
+            <a:r>
+              <a:rPr sz="1600" b="0" i="0">
+                <a:solidFill>
+                  <a:srgbClr val="3C4452"/>
+                </a:solidFill>
+                <a:latin typeface="Calibri"/>
+              </a:rPr>
+              <a:t>–  Receber exatamente o que comprar, quanto e em qual produto — sem ambiguidade</a:t>
+            </a:r>
+          </a:p>
+          <a:p>
+            <a:pPr algn="l">
+              <a:spcAft>
+                <a:spcPts val="1000"/>
+              </a:spcAft>
+            </a:pPr>
+            <a:r>
+              <a:rPr sz="2000" b="1" i="0">
+                <a:solidFill>
+                  <a:srgbClr val="0B1F3A"/>
+                </a:solidFill>
+                <a:latin typeface="Calibri"/>
+              </a:rPr>
+              <a:t>Acompanhamento contínuo</a:t>
+            </a:r>
+          </a:p>
+          <a:p>
+            <a:pPr algn="l" lvl="1">
+              <a:spcAft>
+                <a:spcPts val="500"/>
+              </a:spcAft>
+            </a:pPr>
+            <a:r>
+              <a:rPr sz="1600" b="0" i="0">
+                <a:solidFill>
+                  <a:srgbClr val="3C4452"/>
+                </a:solidFill>
+                <a:latin typeface="Calibri"/>
+              </a:rPr>
+              <a:t>–  Saber se a carteira ainda está aderente ao alvo após movimentos de mercado</a:t>
+            </a:r>
+          </a:p>
+          <a:p>
+            <a:pPr algn="l" lvl="1">
+              <a:spcAft>
+                <a:spcPts val="500"/>
+              </a:spcAft>
+            </a:pPr>
+            <a:r>
+              <a:rPr sz="1600" b="0" i="0">
+                <a:solidFill>
+                  <a:srgbClr val="3C4452"/>
+                </a:solidFill>
+                <a:latin typeface="Calibri"/>
+              </a:rPr>
+              <a:t>–  Ser avisado quando houver oportunidade de melhora ou desvio relevante</a:t>
+            </a:r>
+          </a:p>
         </p:txBody>
       </p:sp>
       <p:sp>
@@ -7959,7 +8087,7 @@
         <p:spPr>
           <a:xfrm>
             <a:off x="502920" y="868680"/>
-            <a:ext cx="11155680" cy="1005840"/>
+            <a:ext cx="11155680" cy="731520"/>
           </a:xfrm>
           <a:prstGeom prst="rect">
             <a:avLst/>
@@ -7978,13 +8106,13 @@
               </a:spcAft>
             </a:pPr>
             <a:r>
-              <a:rPr sz="3400" b="1" i="0">
+              <a:rPr sz="3000" b="1" i="0">
                 <a:solidFill>
                   <a:srgbClr val="FFFFFF"/>
                 </a:solidFill>
                 <a:latin typeface="Calibri"/>
               </a:rPr>
-              <a:t>Etapa 5 — A decisão</a:t>
+              <a:t>Etapa 5 — A decisão: water-filling</a:t>
             </a:r>
           </a:p>
           <a:p>
@@ -7994,13 +8122,13 @@
               </a:spcAft>
             </a:pPr>
             <a:r>
-              <a:rPr sz="1600" b="0" i="1">
+              <a:rPr sz="1400" b="0" i="1">
                 <a:solidFill>
                   <a:srgbClr val="17B8C4"/>
                 </a:solidFill>
                 <a:latin typeface="Calibri"/>
               </a:rPr>
-              <a:t>O coração do modelo: onde colocar o caixa</a:t>
+              <a:t>O caixa vai primeiro para quem está mais longe do alvo</a:t>
             </a:r>
           </a:p>
         </p:txBody>
@@ -8013,8 +8141,8 @@
         </p:nvSpPr>
         <p:spPr>
           <a:xfrm>
-            <a:off x="640080" y="2194560"/>
-            <a:ext cx="6766560" cy="4023360"/>
+            <a:off x="502920" y="1828800"/>
+            <a:ext cx="3840480" cy="4389120"/>
           </a:xfrm>
           <a:prstGeom prst="rect">
             <a:avLst/>
@@ -8029,11 +8157,11 @@
           <a:p>
             <a:pPr algn="l">
               <a:spcAft>
-                <a:spcPts val="200"/>
+                <a:spcPts val="100"/>
               </a:spcAft>
             </a:pPr>
             <a:r>
-              <a:rPr sz="2000" b="1" i="0">
+              <a:rPr sz="1600" b="1" i="0">
                 <a:solidFill>
                   <a:srgbClr val="FFFFFF"/>
                 </a:solidFill>
@@ -8045,59 +8173,59 @@
           <a:p>
             <a:pPr algn="l">
               <a:spcAft>
-                <a:spcPts val="1400"/>
+                <a:spcPts val="1200"/>
               </a:spcAft>
             </a:pPr>
             <a:r>
-              <a:rPr sz="1500" b="0" i="0">
+              <a:rPr sz="1200" b="0" i="0">
                 <a:solidFill>
                   <a:srgbClr val="C9D6E6"/>
                 </a:solidFill>
                 <a:latin typeface="Calibri"/>
               </a:rPr>
-              <a:t>Distribui o caixa fechando primeiro os maiores gaps em relação ao alvo — sem nunca vender</a:t>
+              <a:t>Fecha os maiores gaps primeiro — sem nunca vender</a:t>
             </a:r>
           </a:p>
           <a:p>
             <a:pPr algn="l">
               <a:spcAft>
-                <a:spcPts val="200"/>
+                <a:spcPts val="100"/>
               </a:spcAft>
             </a:pPr>
             <a:r>
-              <a:rPr sz="2000" b="1" i="0">
+              <a:rPr sz="1600" b="1" i="0">
                 <a:solidFill>
                   <a:srgbClr val="FFFFFF"/>
                 </a:solidFill>
                 <a:latin typeface="Calibri"/>
               </a:rPr>
-              <a:t>Respeita os limites</a:t>
+              <a:t>Respeita limites</a:t>
             </a:r>
           </a:p>
           <a:p>
             <a:pPr algn="l">
               <a:spcAft>
-                <a:spcPts val="1400"/>
+                <a:spcPts val="1200"/>
               </a:spcAft>
             </a:pPr>
             <a:r>
-              <a:rPr sz="1500" b="0" i="0">
+              <a:rPr sz="1200" b="0" i="0">
                 <a:solidFill>
                   <a:srgbClr val="C9D6E6"/>
                 </a:solidFill>
                 <a:latin typeface="Calibri"/>
               </a:rPr>
-              <a:t>Aplicação mínima e teto de concentração, considerando o que o cliente já tem</a:t>
+              <a:t>Aplicação mínima + teto de concentração sobre posição já existente</a:t>
             </a:r>
           </a:p>
           <a:p>
             <a:pPr algn="l">
               <a:spcAft>
-                <a:spcPts val="200"/>
+                <a:spcPts val="100"/>
               </a:spcAft>
             </a:pPr>
             <a:r>
-              <a:rPr sz="2000" b="1" i="0">
+              <a:rPr sz="1600" b="1" i="0">
                 <a:solidFill>
                   <a:srgbClr val="FFFFFF"/>
                 </a:solidFill>
@@ -8109,17 +8237,17 @@
           <a:p>
             <a:pPr algn="l">
               <a:spcAft>
-                <a:spcPts val="1400"/>
+                <a:spcPts val="1200"/>
               </a:spcAft>
             </a:pPr>
             <a:r>
-              <a:rPr sz="1500" b="0" i="0">
+              <a:rPr sz="1200" b="0" i="0">
                 <a:solidFill>
                   <a:srgbClr val="C9D6E6"/>
                 </a:solidFill>
                 <a:latin typeface="Calibri"/>
               </a:rPr>
-              <a:t>Resíduos caem numa categoria-coringa (AV1010) com tratamento dedicado</a:t>
+              <a:t>Resíduo vai para AV1010 (caixa/RF curto), com força se necessário</a:t>
             </a:r>
           </a:p>
         </p:txBody>
@@ -8132,16 +8260,18 @@
         </p:nvSpPr>
         <p:spPr>
           <a:xfrm>
-            <a:off x="7772400" y="2743200"/>
-            <a:ext cx="777240" cy="3017520"/>
-          </a:xfrm>
-          <a:prstGeom prst="rect">
-            <a:avLst/>
-          </a:prstGeom>
-          <a:noFill/>
-          <a:ln w="12700">
+            <a:off x="4434840" y="1828800"/>
+            <a:ext cx="2011680" cy="420624"/>
+          </a:xfrm>
+          <a:prstGeom prst="rect">
+            <a:avLst/>
+          </a:prstGeom>
+          <a:solidFill>
+            <a:srgbClr val="1E5AA8"/>
+          </a:solidFill>
+          <a:ln w="6350">
             <a:solidFill>
-              <a:srgbClr val="6B7280"/>
+              <a:srgbClr val="1E3A6E"/>
             </a:solidFill>
           </a:ln>
           <a:effectLst/>
@@ -8161,10 +8291,19 @@
           </a:fontRef>
         </p:style>
         <p:txBody>
-          <a:bodyPr rtlCol="0" anchor="ctr"/>
+          <a:bodyPr rtlCol="0" anchor="ctr" wrap="none"/>
           <a:lstStyle/>
           <a:p>
             <a:pPr algn="ctr"/>
+            <a:r>
+              <a:rPr sz="1100" b="1">
+                <a:solidFill>
+                  <a:srgbClr val="FFFFFF"/>
+                </a:solidFill>
+                <a:latin typeface="Calibri"/>
+              </a:rPr>
+              <a:t>Categoria</a:t>
+            </a:r>
           </a:p>
         </p:txBody>
       </p:sp>
@@ -8176,17 +8315,19 @@
         </p:nvSpPr>
         <p:spPr>
           <a:xfrm>
-            <a:off x="7772400" y="4114800"/>
-            <a:ext cx="777240" cy="1645920"/>
-          </a:xfrm>
-          <a:prstGeom prst="rect">
-            <a:avLst/>
-          </a:prstGeom>
-          <a:solidFill>
-            <a:srgbClr val="17B8C4"/>
-          </a:solidFill>
-          <a:ln>
-            <a:noFill/>
+            <a:off x="6446520" y="1828800"/>
+            <a:ext cx="640080" cy="420624"/>
+          </a:xfrm>
+          <a:prstGeom prst="rect">
+            <a:avLst/>
+          </a:prstGeom>
+          <a:solidFill>
+            <a:srgbClr val="1E5AA8"/>
+          </a:solidFill>
+          <a:ln w="6350">
+            <a:solidFill>
+              <a:srgbClr val="1E3A6E"/>
+            </a:solidFill>
           </a:ln>
           <a:effectLst/>
         </p:spPr>
@@ -8205,66 +8346,42 @@
           </a:fontRef>
         </p:style>
         <p:txBody>
-          <a:bodyPr rtlCol="0" anchor="ctr"/>
+          <a:bodyPr rtlCol="0" anchor="ctr" wrap="none"/>
           <a:lstStyle/>
           <a:p>
             <a:pPr algn="ctr"/>
-          </a:p>
-        </p:txBody>
-      </p:sp>
-      <p:sp>
-        <p:nvSpPr>
-          <p:cNvPr id="8" name="TextBox 7"/>
-          <p:cNvSpPr txBox="1"/>
-          <p:nvPr/>
-        </p:nvSpPr>
-        <p:spPr>
-          <a:xfrm>
-            <a:off x="7680960" y="5852160"/>
-            <a:ext cx="960120" cy="365760"/>
-          </a:xfrm>
-          <a:prstGeom prst="rect">
-            <a:avLst/>
-          </a:prstGeom>
-          <a:noFill/>
-        </p:spPr>
-        <p:txBody>
-          <a:bodyPr wrap="none">
-            <a:spAutoFit/>
-          </a:bodyPr>
-          <a:lstStyle/>
-          <a:p>
-            <a:pPr algn="ctr"/>
-            <a:r>
-              <a:rPr sz="1000">
-                <a:solidFill>
-                  <a:srgbClr val="C9D6E6"/>
-                </a:solidFill>
-                <a:latin typeface="Calibri"/>
-              </a:rPr>
-              <a:t>Renda Fixa</a:t>
-            </a:r>
-          </a:p>
-        </p:txBody>
-      </p:sp>
-      <p:sp>
-        <p:nvSpPr>
-          <p:cNvPr id="9" name="Rectangle 8"/>
+            <a:r>
+              <a:rPr sz="1100" b="1">
+                <a:solidFill>
+                  <a:srgbClr val="FFFFFF"/>
+                </a:solidFill>
+                <a:latin typeface="Calibri"/>
+              </a:rPr>
+              <a:t>Atual</a:t>
+            </a:r>
+          </a:p>
+        </p:txBody>
+      </p:sp>
+      <p:sp>
+        <p:nvSpPr>
+          <p:cNvPr id="8" name="Rectangle 7"/>
           <p:cNvSpPr/>
           <p:nvPr/>
         </p:nvSpPr>
         <p:spPr>
           <a:xfrm>
-            <a:off x="8778240" y="2743200"/>
-            <a:ext cx="777240" cy="3017520"/>
-          </a:xfrm>
-          <a:prstGeom prst="rect">
-            <a:avLst/>
-          </a:prstGeom>
-          <a:noFill/>
-          <a:ln w="12700">
+            <a:off x="7086600" y="1828800"/>
+            <a:ext cx="640080" cy="420624"/>
+          </a:xfrm>
+          <a:prstGeom prst="rect">
+            <a:avLst/>
+          </a:prstGeom>
+          <a:solidFill>
+            <a:srgbClr val="1E5AA8"/>
+          </a:solidFill>
+          <a:ln w="6350">
             <a:solidFill>
-              <a:srgbClr val="6B7280"/>
+              <a:srgbClr val="1E3A6E"/>
             </a:solidFill>
           </a:ln>
           <a:effectLst/>
@@ -8284,32 +8401,43 @@
           </a:fontRef>
         </p:style>
         <p:txBody>
-          <a:bodyPr rtlCol="0" anchor="ctr"/>
+          <a:bodyPr rtlCol="0" anchor="ctr" wrap="none"/>
           <a:lstStyle/>
           <a:p>
             <a:pPr algn="ctr"/>
-          </a:p>
-        </p:txBody>
-      </p:sp>
-      <p:sp>
-        <p:nvSpPr>
-          <p:cNvPr id="10" name="Rectangle 9"/>
+            <a:r>
+              <a:rPr sz="1100" b="1">
+                <a:solidFill>
+                  <a:srgbClr val="FFFFFF"/>
+                </a:solidFill>
+                <a:latin typeface="Calibri"/>
+              </a:rPr>
+              <a:t>Alvo</a:t>
+            </a:r>
+          </a:p>
+        </p:txBody>
+      </p:sp>
+      <p:sp>
+        <p:nvSpPr>
+          <p:cNvPr id="9" name="Rectangle 8"/>
           <p:cNvSpPr/>
           <p:nvPr/>
         </p:nvSpPr>
         <p:spPr>
           <a:xfrm>
-            <a:off x="8778240" y="4572000"/>
-            <a:ext cx="777240" cy="1188720"/>
-          </a:xfrm>
-          <a:prstGeom prst="rect">
-            <a:avLst/>
-          </a:prstGeom>
-          <a:solidFill>
-            <a:srgbClr val="17B8C4"/>
-          </a:solidFill>
-          <a:ln>
-            <a:noFill/>
+            <a:off x="7726680" y="1828800"/>
+            <a:ext cx="594360" cy="420624"/>
+          </a:xfrm>
+          <a:prstGeom prst="rect">
+            <a:avLst/>
+          </a:prstGeom>
+          <a:solidFill>
+            <a:srgbClr val="1E5AA8"/>
+          </a:solidFill>
+          <a:ln w="6350">
+            <a:solidFill>
+              <a:srgbClr val="1E3A6E"/>
+            </a:solidFill>
           </a:ln>
           <a:effectLst/>
         </p:spPr>
@@ -8328,66 +8456,42 @@
           </a:fontRef>
         </p:style>
         <p:txBody>
-          <a:bodyPr rtlCol="0" anchor="ctr"/>
+          <a:bodyPr rtlCol="0" anchor="ctr" wrap="none"/>
           <a:lstStyle/>
           <a:p>
             <a:pPr algn="ctr"/>
-          </a:p>
-        </p:txBody>
-      </p:sp>
-      <p:sp>
-        <p:nvSpPr>
-          <p:cNvPr id="11" name="TextBox 10"/>
-          <p:cNvSpPr txBox="1"/>
-          <p:nvPr/>
-        </p:nvSpPr>
-        <p:spPr>
-          <a:xfrm>
-            <a:off x="8686800" y="5852160"/>
-            <a:ext cx="960120" cy="365760"/>
-          </a:xfrm>
-          <a:prstGeom prst="rect">
-            <a:avLst/>
-          </a:prstGeom>
-          <a:noFill/>
-        </p:spPr>
-        <p:txBody>
-          <a:bodyPr wrap="none">
-            <a:spAutoFit/>
-          </a:bodyPr>
-          <a:lstStyle/>
-          <a:p>
-            <a:pPr algn="ctr"/>
-            <a:r>
-              <a:rPr sz="1000">
-                <a:solidFill>
-                  <a:srgbClr val="C9D6E6"/>
-                </a:solidFill>
-                <a:latin typeface="Calibri"/>
-              </a:rPr>
-              <a:t>Ações</a:t>
-            </a:r>
-          </a:p>
-        </p:txBody>
-      </p:sp>
-      <p:sp>
-        <p:nvSpPr>
-          <p:cNvPr id="12" name="Rectangle 11"/>
+            <a:r>
+              <a:rPr sz="1100" b="1">
+                <a:solidFill>
+                  <a:srgbClr val="FFFFFF"/>
+                </a:solidFill>
+                <a:latin typeface="Calibri"/>
+              </a:rPr>
+              <a:t>Gap</a:t>
+            </a:r>
+          </a:p>
+        </p:txBody>
+      </p:sp>
+      <p:sp>
+        <p:nvSpPr>
+          <p:cNvPr id="10" name="Rectangle 9"/>
           <p:cNvSpPr/>
           <p:nvPr/>
         </p:nvSpPr>
         <p:spPr>
           <a:xfrm>
-            <a:off x="9784080" y="2743200"/>
-            <a:ext cx="777240" cy="3017520"/>
-          </a:xfrm>
-          <a:prstGeom prst="rect">
-            <a:avLst/>
-          </a:prstGeom>
-          <a:noFill/>
-          <a:ln w="12700">
+            <a:off x="8321040" y="1828800"/>
+            <a:ext cx="868680" cy="420624"/>
+          </a:xfrm>
+          <a:prstGeom prst="rect">
+            <a:avLst/>
+          </a:prstGeom>
+          <a:solidFill>
+            <a:srgbClr val="1E5AA8"/>
+          </a:solidFill>
+          <a:ln w="6350">
             <a:solidFill>
-              <a:srgbClr val="6B7280"/>
+              <a:srgbClr val="1E3A6E"/>
             </a:solidFill>
           </a:ln>
           <a:effectLst/>
@@ -8407,32 +8511,43 @@
           </a:fontRef>
         </p:style>
         <p:txBody>
-          <a:bodyPr rtlCol="0" anchor="ctr"/>
+          <a:bodyPr rtlCol="0" anchor="ctr" wrap="none"/>
           <a:lstStyle/>
           <a:p>
             <a:pPr algn="ctr"/>
-          </a:p>
-        </p:txBody>
-      </p:sp>
-      <p:sp>
-        <p:nvSpPr>
-          <p:cNvPr id="13" name="Rectangle 12"/>
+            <a:r>
+              <a:rPr sz="1100" b="1">
+                <a:solidFill>
+                  <a:srgbClr val="FFFFFF"/>
+                </a:solidFill>
+                <a:latin typeface="Calibri"/>
+              </a:rPr>
+              <a:t>Compra</a:t>
+            </a:r>
+          </a:p>
+        </p:txBody>
+      </p:sp>
+      <p:sp>
+        <p:nvSpPr>
+          <p:cNvPr id="11" name="Rectangle 10"/>
           <p:cNvSpPr/>
           <p:nvPr/>
         </p:nvSpPr>
         <p:spPr>
           <a:xfrm>
-            <a:off x="9784080" y="3566160"/>
-            <a:ext cx="777240" cy="2194560"/>
-          </a:xfrm>
-          <a:prstGeom prst="rect">
-            <a:avLst/>
-          </a:prstGeom>
-          <a:solidFill>
-            <a:srgbClr val="17B8C4"/>
-          </a:solidFill>
-          <a:ln>
-            <a:noFill/>
+            <a:off x="9189720" y="1828800"/>
+            <a:ext cx="777240" cy="420624"/>
+          </a:xfrm>
+          <a:prstGeom prst="rect">
+            <a:avLst/>
+          </a:prstGeom>
+          <a:solidFill>
+            <a:srgbClr val="1E5AA8"/>
+          </a:solidFill>
+          <a:ln w="6350">
+            <a:solidFill>
+              <a:srgbClr val="1E3A6E"/>
+            </a:solidFill>
           </a:ln>
           <a:effectLst/>
         </p:spPr>
@@ -8451,66 +8566,42 @@
           </a:fontRef>
         </p:style>
         <p:txBody>
-          <a:bodyPr rtlCol="0" anchor="ctr"/>
+          <a:bodyPr rtlCol="0" anchor="ctr" wrap="none"/>
           <a:lstStyle/>
           <a:p>
             <a:pPr algn="ctr"/>
-          </a:p>
-        </p:txBody>
-      </p:sp>
-      <p:sp>
-        <p:nvSpPr>
-          <p:cNvPr id="14" name="TextBox 13"/>
-          <p:cNvSpPr txBox="1"/>
-          <p:nvPr/>
-        </p:nvSpPr>
-        <p:spPr>
-          <a:xfrm>
-            <a:off x="9692640" y="5852160"/>
-            <a:ext cx="960120" cy="365760"/>
-          </a:xfrm>
-          <a:prstGeom prst="rect">
-            <a:avLst/>
-          </a:prstGeom>
-          <a:noFill/>
-        </p:spPr>
-        <p:txBody>
-          <a:bodyPr wrap="none">
-            <a:spAutoFit/>
-          </a:bodyPr>
-          <a:lstStyle/>
-          <a:p>
-            <a:pPr algn="ctr"/>
-            <a:r>
-              <a:rPr sz="1000">
-                <a:solidFill>
-                  <a:srgbClr val="C9D6E6"/>
-                </a:solidFill>
-                <a:latin typeface="Calibri"/>
-              </a:rPr>
-              <a:t>Fundos</a:t>
-            </a:r>
-          </a:p>
-        </p:txBody>
-      </p:sp>
-      <p:sp>
-        <p:nvSpPr>
-          <p:cNvPr id="15" name="Rectangle 14"/>
+            <a:r>
+              <a:rPr sz="1100" b="1">
+                <a:solidFill>
+                  <a:srgbClr val="FFFFFF"/>
+                </a:solidFill>
+                <a:latin typeface="Calibri"/>
+              </a:rPr>
+              <a:t>Depois</a:t>
+            </a:r>
+          </a:p>
+        </p:txBody>
+      </p:sp>
+      <p:sp>
+        <p:nvSpPr>
+          <p:cNvPr id="12" name="Rectangle 11"/>
           <p:cNvSpPr/>
           <p:nvPr/>
         </p:nvSpPr>
         <p:spPr>
           <a:xfrm>
-            <a:off x="10789920" y="2743200"/>
-            <a:ext cx="777240" cy="3017520"/>
-          </a:xfrm>
-          <a:prstGeom prst="rect">
-            <a:avLst/>
-          </a:prstGeom>
-          <a:noFill/>
-          <a:ln w="12700">
+            <a:off x="4434840" y="2249424"/>
+            <a:ext cx="2011680" cy="420624"/>
+          </a:xfrm>
+          <a:prstGeom prst="rect">
+            <a:avLst/>
+          </a:prstGeom>
+          <a:solidFill>
+            <a:srgbClr val="0F2445"/>
+          </a:solidFill>
+          <a:ln w="6350">
             <a:solidFill>
-              <a:srgbClr val="6B7280"/>
+              <a:srgbClr val="1E3A6E"/>
             </a:solidFill>
           </a:ln>
           <a:effectLst/>
@@ -8530,32 +8621,43 @@
           </a:fontRef>
         </p:style>
         <p:txBody>
-          <a:bodyPr rtlCol="0" anchor="ctr"/>
+          <a:bodyPr rtlCol="0" anchor="ctr" wrap="none"/>
           <a:lstStyle/>
           <a:p>
             <a:pPr algn="ctr"/>
-          </a:p>
-        </p:txBody>
-      </p:sp>
-      <p:sp>
-        <p:nvSpPr>
-          <p:cNvPr id="16" name="Rectangle 15"/>
+            <a:r>
+              <a:rPr sz="1200" b="0">
+                <a:solidFill>
+                  <a:srgbClr val="FFFFFF"/>
+                </a:solidFill>
+                <a:latin typeface="Calibri"/>
+              </a:rPr>
+              <a:t>AV1010  RF Curto</a:t>
+            </a:r>
+          </a:p>
+        </p:txBody>
+      </p:sp>
+      <p:sp>
+        <p:nvSpPr>
+          <p:cNvPr id="13" name="Rectangle 12"/>
           <p:cNvSpPr/>
           <p:nvPr/>
         </p:nvSpPr>
         <p:spPr>
           <a:xfrm>
-            <a:off x="10789920" y="4846320"/>
-            <a:ext cx="777240" cy="914400"/>
-          </a:xfrm>
-          <a:prstGeom prst="rect">
-            <a:avLst/>
-          </a:prstGeom>
-          <a:solidFill>
-            <a:srgbClr val="17B8C4"/>
-          </a:solidFill>
-          <a:ln>
-            <a:noFill/>
+            <a:off x="6446520" y="2249424"/>
+            <a:ext cx="640080" cy="420624"/>
+          </a:xfrm>
+          <a:prstGeom prst="rect">
+            <a:avLst/>
+          </a:prstGeom>
+          <a:solidFill>
+            <a:srgbClr val="0F2445"/>
+          </a:solidFill>
+          <a:ln w="6350">
+            <a:solidFill>
+              <a:srgbClr val="1E3A6E"/>
+            </a:solidFill>
           </a:ln>
           <a:effectLst/>
         </p:spPr>
@@ -8574,23 +8676,1902 @@
           </a:fontRef>
         </p:style>
         <p:txBody>
-          <a:bodyPr rtlCol="0" anchor="ctr"/>
+          <a:bodyPr rtlCol="0" anchor="ctr" wrap="none"/>
           <a:lstStyle/>
           <a:p>
             <a:pPr algn="ctr"/>
-          </a:p>
-        </p:txBody>
-      </p:sp>
-      <p:sp>
-        <p:nvSpPr>
-          <p:cNvPr id="17" name="TextBox 16"/>
+            <a:r>
+              <a:rPr sz="1200" b="0">
+                <a:solidFill>
+                  <a:srgbClr val="FFFFFF"/>
+                </a:solidFill>
+                <a:latin typeface="Calibri"/>
+              </a:rPr>
+              <a:t>22%</a:t>
+            </a:r>
+          </a:p>
+        </p:txBody>
+      </p:sp>
+      <p:sp>
+        <p:nvSpPr>
+          <p:cNvPr id="14" name="Rectangle 13"/>
+          <p:cNvSpPr/>
+          <p:nvPr/>
+        </p:nvSpPr>
+        <p:spPr>
+          <a:xfrm>
+            <a:off x="7086600" y="2249424"/>
+            <a:ext cx="640080" cy="420624"/>
+          </a:xfrm>
+          <a:prstGeom prst="rect">
+            <a:avLst/>
+          </a:prstGeom>
+          <a:solidFill>
+            <a:srgbClr val="0F2445"/>
+          </a:solidFill>
+          <a:ln w="6350">
+            <a:solidFill>
+              <a:srgbClr val="1E3A6E"/>
+            </a:solidFill>
+          </a:ln>
+          <a:effectLst/>
+        </p:spPr>
+        <p:style>
+          <a:lnRef idx="1">
+            <a:schemeClr val="accent1"/>
+          </a:lnRef>
+          <a:fillRef idx="3">
+            <a:schemeClr val="accent1"/>
+          </a:fillRef>
+          <a:effectRef idx="2">
+            <a:schemeClr val="accent1"/>
+          </a:effectRef>
+          <a:fontRef idx="minor">
+            <a:schemeClr val="lt1"/>
+          </a:fontRef>
+        </p:style>
+        <p:txBody>
+          <a:bodyPr rtlCol="0" anchor="ctr" wrap="none"/>
+          <a:lstStyle/>
+          <a:p>
+            <a:pPr algn="ctr"/>
+            <a:r>
+              <a:rPr sz="1200" b="0">
+                <a:solidFill>
+                  <a:srgbClr val="FFFFFF"/>
+                </a:solidFill>
+                <a:latin typeface="Calibri"/>
+              </a:rPr>
+              <a:t>15%</a:t>
+            </a:r>
+          </a:p>
+        </p:txBody>
+      </p:sp>
+      <p:sp>
+        <p:nvSpPr>
+          <p:cNvPr id="15" name="Rectangle 14"/>
+          <p:cNvSpPr/>
+          <p:nvPr/>
+        </p:nvSpPr>
+        <p:spPr>
+          <a:xfrm>
+            <a:off x="7726680" y="2249424"/>
+            <a:ext cx="594360" cy="420624"/>
+          </a:xfrm>
+          <a:prstGeom prst="rect">
+            <a:avLst/>
+          </a:prstGeom>
+          <a:solidFill>
+            <a:srgbClr val="0F2445"/>
+          </a:solidFill>
+          <a:ln w="6350">
+            <a:solidFill>
+              <a:srgbClr val="1E3A6E"/>
+            </a:solidFill>
+          </a:ln>
+          <a:effectLst/>
+        </p:spPr>
+        <p:style>
+          <a:lnRef idx="1">
+            <a:schemeClr val="accent1"/>
+          </a:lnRef>
+          <a:fillRef idx="3">
+            <a:schemeClr val="accent1"/>
+          </a:fillRef>
+          <a:effectRef idx="2">
+            <a:schemeClr val="accent1"/>
+          </a:effectRef>
+          <a:fontRef idx="minor">
+            <a:schemeClr val="lt1"/>
+          </a:fontRef>
+        </p:style>
+        <p:txBody>
+          <a:bodyPr rtlCol="0" anchor="ctr" wrap="none"/>
+          <a:lstStyle/>
+          <a:p>
+            <a:pPr algn="ctr"/>
+            <a:r>
+              <a:rPr sz="1200" b="0">
+                <a:solidFill>
+                  <a:srgbClr val="FFFFFF"/>
+                </a:solidFill>
+                <a:latin typeface="Calibri"/>
+              </a:rPr>
+              <a:t>–</a:t>
+            </a:r>
+          </a:p>
+        </p:txBody>
+      </p:sp>
+      <p:sp>
+        <p:nvSpPr>
+          <p:cNvPr id="16" name="Rectangle 15"/>
+          <p:cNvSpPr/>
+          <p:nvPr/>
+        </p:nvSpPr>
+        <p:spPr>
+          <a:xfrm>
+            <a:off x="8321040" y="2249424"/>
+            <a:ext cx="868680" cy="420624"/>
+          </a:xfrm>
+          <a:prstGeom prst="rect">
+            <a:avLst/>
+          </a:prstGeom>
+          <a:solidFill>
+            <a:srgbClr val="0F2445"/>
+          </a:solidFill>
+          <a:ln w="6350">
+            <a:solidFill>
+              <a:srgbClr val="1E3A6E"/>
+            </a:solidFill>
+          </a:ln>
+          <a:effectLst/>
+        </p:spPr>
+        <p:style>
+          <a:lnRef idx="1">
+            <a:schemeClr val="accent1"/>
+          </a:lnRef>
+          <a:fillRef idx="3">
+            <a:schemeClr val="accent1"/>
+          </a:fillRef>
+          <a:effectRef idx="2">
+            <a:schemeClr val="accent1"/>
+          </a:effectRef>
+          <a:fontRef idx="minor">
+            <a:schemeClr val="lt1"/>
+          </a:fontRef>
+        </p:style>
+        <p:txBody>
+          <a:bodyPr rtlCol="0" anchor="ctr" wrap="none"/>
+          <a:lstStyle/>
+          <a:p>
+            <a:pPr algn="ctr"/>
+            <a:r>
+              <a:rPr sz="1200" b="0">
+                <a:solidFill>
+                  <a:srgbClr val="FFFFFF"/>
+                </a:solidFill>
+                <a:latin typeface="Calibri"/>
+              </a:rPr>
+              <a:t>US$ 0</a:t>
+            </a:r>
+          </a:p>
+        </p:txBody>
+      </p:sp>
+      <p:sp>
+        <p:nvSpPr>
+          <p:cNvPr id="17" name="Rectangle 16"/>
+          <p:cNvSpPr/>
+          <p:nvPr/>
+        </p:nvSpPr>
+        <p:spPr>
+          <a:xfrm>
+            <a:off x="9189720" y="2249424"/>
+            <a:ext cx="777240" cy="420624"/>
+          </a:xfrm>
+          <a:prstGeom prst="rect">
+            <a:avLst/>
+          </a:prstGeom>
+          <a:solidFill>
+            <a:srgbClr val="0F2445"/>
+          </a:solidFill>
+          <a:ln w="6350">
+            <a:solidFill>
+              <a:srgbClr val="1E3A6E"/>
+            </a:solidFill>
+          </a:ln>
+          <a:effectLst/>
+        </p:spPr>
+        <p:style>
+          <a:lnRef idx="1">
+            <a:schemeClr val="accent1"/>
+          </a:lnRef>
+          <a:fillRef idx="3">
+            <a:schemeClr val="accent1"/>
+          </a:fillRef>
+          <a:effectRef idx="2">
+            <a:schemeClr val="accent1"/>
+          </a:effectRef>
+          <a:fontRef idx="minor">
+            <a:schemeClr val="lt1"/>
+          </a:fontRef>
+        </p:style>
+        <p:txBody>
+          <a:bodyPr rtlCol="0" anchor="ctr" wrap="none"/>
+          <a:lstStyle/>
+          <a:p>
+            <a:pPr algn="ctr"/>
+            <a:r>
+              <a:rPr sz="1200" b="0">
+                <a:solidFill>
+                  <a:srgbClr val="4CE8A8"/>
+                </a:solidFill>
+                <a:latin typeface="Calibri"/>
+              </a:rPr>
+              <a:t>20%</a:t>
+            </a:r>
+          </a:p>
+        </p:txBody>
+      </p:sp>
+      <p:sp>
+        <p:nvSpPr>
+          <p:cNvPr id="18" name="Rectangle 17"/>
+          <p:cNvSpPr/>
+          <p:nvPr/>
+        </p:nvSpPr>
+        <p:spPr>
+          <a:xfrm>
+            <a:off x="4434840" y="2670048"/>
+            <a:ext cx="2011680" cy="420624"/>
+          </a:xfrm>
+          <a:prstGeom prst="rect">
+            <a:avLst/>
+          </a:prstGeom>
+          <a:solidFill>
+            <a:srgbClr val="142A50"/>
+          </a:solidFill>
+          <a:ln w="6350">
+            <a:solidFill>
+              <a:srgbClr val="1E3A6E"/>
+            </a:solidFill>
+          </a:ln>
+          <a:effectLst/>
+        </p:spPr>
+        <p:style>
+          <a:lnRef idx="1">
+            <a:schemeClr val="accent1"/>
+          </a:lnRef>
+          <a:fillRef idx="3">
+            <a:schemeClr val="accent1"/>
+          </a:fillRef>
+          <a:effectRef idx="2">
+            <a:schemeClr val="accent1"/>
+          </a:effectRef>
+          <a:fontRef idx="minor">
+            <a:schemeClr val="lt1"/>
+          </a:fontRef>
+        </p:style>
+        <p:txBody>
+          <a:bodyPr rtlCol="0" anchor="ctr" wrap="none"/>
+          <a:lstStyle/>
+          <a:p>
+            <a:pPr algn="ctr"/>
+            <a:r>
+              <a:rPr sz="1200" b="0">
+                <a:solidFill>
+                  <a:srgbClr val="FFFFFF"/>
+                </a:solidFill>
+                <a:latin typeface="Calibri"/>
+              </a:rPr>
+              <a:t>AV2020  RF Longo</a:t>
+            </a:r>
+          </a:p>
+        </p:txBody>
+      </p:sp>
+      <p:sp>
+        <p:nvSpPr>
+          <p:cNvPr id="19" name="Rectangle 18"/>
+          <p:cNvSpPr/>
+          <p:nvPr/>
+        </p:nvSpPr>
+        <p:spPr>
+          <a:xfrm>
+            <a:off x="6446520" y="2670048"/>
+            <a:ext cx="640080" cy="420624"/>
+          </a:xfrm>
+          <a:prstGeom prst="rect">
+            <a:avLst/>
+          </a:prstGeom>
+          <a:solidFill>
+            <a:srgbClr val="142A50"/>
+          </a:solidFill>
+          <a:ln w="6350">
+            <a:solidFill>
+              <a:srgbClr val="1E3A6E"/>
+            </a:solidFill>
+          </a:ln>
+          <a:effectLst/>
+        </p:spPr>
+        <p:style>
+          <a:lnRef idx="1">
+            <a:schemeClr val="accent1"/>
+          </a:lnRef>
+          <a:fillRef idx="3">
+            <a:schemeClr val="accent1"/>
+          </a:fillRef>
+          <a:effectRef idx="2">
+            <a:schemeClr val="accent1"/>
+          </a:effectRef>
+          <a:fontRef idx="minor">
+            <a:schemeClr val="lt1"/>
+          </a:fontRef>
+        </p:style>
+        <p:txBody>
+          <a:bodyPr rtlCol="0" anchor="ctr" wrap="none"/>
+          <a:lstStyle/>
+          <a:p>
+            <a:pPr algn="ctr"/>
+            <a:r>
+              <a:rPr sz="1200" b="0">
+                <a:solidFill>
+                  <a:srgbClr val="FFFFFF"/>
+                </a:solidFill>
+                <a:latin typeface="Calibri"/>
+              </a:rPr>
+              <a:t>8%</a:t>
+            </a:r>
+          </a:p>
+        </p:txBody>
+      </p:sp>
+      <p:sp>
+        <p:nvSpPr>
+          <p:cNvPr id="20" name="Rectangle 19"/>
+          <p:cNvSpPr/>
+          <p:nvPr/>
+        </p:nvSpPr>
+        <p:spPr>
+          <a:xfrm>
+            <a:off x="7086600" y="2670048"/>
+            <a:ext cx="640080" cy="420624"/>
+          </a:xfrm>
+          <a:prstGeom prst="rect">
+            <a:avLst/>
+          </a:prstGeom>
+          <a:solidFill>
+            <a:srgbClr val="142A50"/>
+          </a:solidFill>
+          <a:ln w="6350">
+            <a:solidFill>
+              <a:srgbClr val="1E3A6E"/>
+            </a:solidFill>
+          </a:ln>
+          <a:effectLst/>
+        </p:spPr>
+        <p:style>
+          <a:lnRef idx="1">
+            <a:schemeClr val="accent1"/>
+          </a:lnRef>
+          <a:fillRef idx="3">
+            <a:schemeClr val="accent1"/>
+          </a:fillRef>
+          <a:effectRef idx="2">
+            <a:schemeClr val="accent1"/>
+          </a:effectRef>
+          <a:fontRef idx="minor">
+            <a:schemeClr val="lt1"/>
+          </a:fontRef>
+        </p:style>
+        <p:txBody>
+          <a:bodyPr rtlCol="0" anchor="ctr" wrap="none"/>
+          <a:lstStyle/>
+          <a:p>
+            <a:pPr algn="ctr"/>
+            <a:r>
+              <a:rPr sz="1200" b="0">
+                <a:solidFill>
+                  <a:srgbClr val="FFFFFF"/>
+                </a:solidFill>
+                <a:latin typeface="Calibri"/>
+              </a:rPr>
+              <a:t>20%</a:t>
+            </a:r>
+          </a:p>
+        </p:txBody>
+      </p:sp>
+      <p:sp>
+        <p:nvSpPr>
+          <p:cNvPr id="21" name="Rectangle 20"/>
+          <p:cNvSpPr/>
+          <p:nvPr/>
+        </p:nvSpPr>
+        <p:spPr>
+          <a:xfrm>
+            <a:off x="7726680" y="2670048"/>
+            <a:ext cx="594360" cy="420624"/>
+          </a:xfrm>
+          <a:prstGeom prst="rect">
+            <a:avLst/>
+          </a:prstGeom>
+          <a:solidFill>
+            <a:srgbClr val="142A50"/>
+          </a:solidFill>
+          <a:ln w="6350">
+            <a:solidFill>
+              <a:srgbClr val="1E3A6E"/>
+            </a:solidFill>
+          </a:ln>
+          <a:effectLst/>
+        </p:spPr>
+        <p:style>
+          <a:lnRef idx="1">
+            <a:schemeClr val="accent1"/>
+          </a:lnRef>
+          <a:fillRef idx="3">
+            <a:schemeClr val="accent1"/>
+          </a:fillRef>
+          <a:effectRef idx="2">
+            <a:schemeClr val="accent1"/>
+          </a:effectRef>
+          <a:fontRef idx="minor">
+            <a:schemeClr val="lt1"/>
+          </a:fontRef>
+        </p:style>
+        <p:txBody>
+          <a:bodyPr rtlCol="0" anchor="ctr" wrap="none"/>
+          <a:lstStyle/>
+          <a:p>
+            <a:pPr algn="ctr"/>
+            <a:r>
+              <a:rPr sz="1200" b="0">
+                <a:solidFill>
+                  <a:srgbClr val="FFFFFF"/>
+                </a:solidFill>
+                <a:latin typeface="Calibri"/>
+              </a:rPr>
+              <a:t>12%</a:t>
+            </a:r>
+          </a:p>
+        </p:txBody>
+      </p:sp>
+      <p:sp>
+        <p:nvSpPr>
+          <p:cNvPr id="22" name="Rectangle 21"/>
+          <p:cNvSpPr/>
+          <p:nvPr/>
+        </p:nvSpPr>
+        <p:spPr>
+          <a:xfrm>
+            <a:off x="8321040" y="2670048"/>
+            <a:ext cx="868680" cy="420624"/>
+          </a:xfrm>
+          <a:prstGeom prst="rect">
+            <a:avLst/>
+          </a:prstGeom>
+          <a:solidFill>
+            <a:srgbClr val="142A50"/>
+          </a:solidFill>
+          <a:ln w="6350">
+            <a:solidFill>
+              <a:srgbClr val="1E3A6E"/>
+            </a:solidFill>
+          </a:ln>
+          <a:effectLst/>
+        </p:spPr>
+        <p:style>
+          <a:lnRef idx="1">
+            <a:schemeClr val="accent1"/>
+          </a:lnRef>
+          <a:fillRef idx="3">
+            <a:schemeClr val="accent1"/>
+          </a:fillRef>
+          <a:effectRef idx="2">
+            <a:schemeClr val="accent1"/>
+          </a:effectRef>
+          <a:fontRef idx="minor">
+            <a:schemeClr val="lt1"/>
+          </a:fontRef>
+        </p:style>
+        <p:txBody>
+          <a:bodyPr rtlCol="0" anchor="ctr" wrap="none"/>
+          <a:lstStyle/>
+          <a:p>
+            <a:pPr algn="ctr"/>
+            <a:r>
+              <a:rPr sz="1200" b="0">
+                <a:solidFill>
+                  <a:srgbClr val="17B8C4"/>
+                </a:solidFill>
+                <a:latin typeface="Calibri"/>
+              </a:rPr>
+              <a:t>US$ 36k</a:t>
+            </a:r>
+          </a:p>
+        </p:txBody>
+      </p:sp>
+      <p:sp>
+        <p:nvSpPr>
+          <p:cNvPr id="23" name="Rectangle 22"/>
+          <p:cNvSpPr/>
+          <p:nvPr/>
+        </p:nvSpPr>
+        <p:spPr>
+          <a:xfrm>
+            <a:off x="9189720" y="2670048"/>
+            <a:ext cx="777240" cy="420624"/>
+          </a:xfrm>
+          <a:prstGeom prst="rect">
+            <a:avLst/>
+          </a:prstGeom>
+          <a:solidFill>
+            <a:srgbClr val="142A50"/>
+          </a:solidFill>
+          <a:ln w="6350">
+            <a:solidFill>
+              <a:srgbClr val="1E3A6E"/>
+            </a:solidFill>
+          </a:ln>
+          <a:effectLst/>
+        </p:spPr>
+        <p:style>
+          <a:lnRef idx="1">
+            <a:schemeClr val="accent1"/>
+          </a:lnRef>
+          <a:fillRef idx="3">
+            <a:schemeClr val="accent1"/>
+          </a:fillRef>
+          <a:effectRef idx="2">
+            <a:schemeClr val="accent1"/>
+          </a:effectRef>
+          <a:fontRef idx="minor">
+            <a:schemeClr val="lt1"/>
+          </a:fontRef>
+        </p:style>
+        <p:txBody>
+          <a:bodyPr rtlCol="0" anchor="ctr" wrap="none"/>
+          <a:lstStyle/>
+          <a:p>
+            <a:pPr algn="ctr"/>
+            <a:r>
+              <a:rPr sz="1200" b="0">
+                <a:solidFill>
+                  <a:srgbClr val="4CE8A8"/>
+                </a:solidFill>
+                <a:latin typeface="Calibri"/>
+              </a:rPr>
+              <a:t>20%</a:t>
+            </a:r>
+          </a:p>
+        </p:txBody>
+      </p:sp>
+      <p:sp>
+        <p:nvSpPr>
+          <p:cNvPr id="24" name="Rectangle 23"/>
+          <p:cNvSpPr/>
+          <p:nvPr/>
+        </p:nvSpPr>
+        <p:spPr>
+          <a:xfrm>
+            <a:off x="4434840" y="3090672"/>
+            <a:ext cx="2011680" cy="420624"/>
+          </a:xfrm>
+          <a:prstGeom prst="rect">
+            <a:avLst/>
+          </a:prstGeom>
+          <a:solidFill>
+            <a:srgbClr val="0F2445"/>
+          </a:solidFill>
+          <a:ln w="6350">
+            <a:solidFill>
+              <a:srgbClr val="1E3A6E"/>
+            </a:solidFill>
+          </a:ln>
+          <a:effectLst/>
+        </p:spPr>
+        <p:style>
+          <a:lnRef idx="1">
+            <a:schemeClr val="accent1"/>
+          </a:lnRef>
+          <a:fillRef idx="3">
+            <a:schemeClr val="accent1"/>
+          </a:fillRef>
+          <a:effectRef idx="2">
+            <a:schemeClr val="accent1"/>
+          </a:effectRef>
+          <a:fontRef idx="minor">
+            <a:schemeClr val="lt1"/>
+          </a:fontRef>
+        </p:style>
+        <p:txBody>
+          <a:bodyPr rtlCol="0" anchor="ctr" wrap="none"/>
+          <a:lstStyle/>
+          <a:p>
+            <a:pPr algn="ctr"/>
+            <a:r>
+              <a:rPr sz="1200" b="0">
+                <a:solidFill>
+                  <a:srgbClr val="FFFFFF"/>
+                </a:solidFill>
+                <a:latin typeface="Calibri"/>
+              </a:rPr>
+              <a:t>AV3030  Ações</a:t>
+            </a:r>
+          </a:p>
+        </p:txBody>
+      </p:sp>
+      <p:sp>
+        <p:nvSpPr>
+          <p:cNvPr id="25" name="Rectangle 24"/>
+          <p:cNvSpPr/>
+          <p:nvPr/>
+        </p:nvSpPr>
+        <p:spPr>
+          <a:xfrm>
+            <a:off x="6446520" y="3090672"/>
+            <a:ext cx="640080" cy="420624"/>
+          </a:xfrm>
+          <a:prstGeom prst="rect">
+            <a:avLst/>
+          </a:prstGeom>
+          <a:solidFill>
+            <a:srgbClr val="0F2445"/>
+          </a:solidFill>
+          <a:ln w="6350">
+            <a:solidFill>
+              <a:srgbClr val="1E3A6E"/>
+            </a:solidFill>
+          </a:ln>
+          <a:effectLst/>
+        </p:spPr>
+        <p:style>
+          <a:lnRef idx="1">
+            <a:schemeClr val="accent1"/>
+          </a:lnRef>
+          <a:fillRef idx="3">
+            <a:schemeClr val="accent1"/>
+          </a:fillRef>
+          <a:effectRef idx="2">
+            <a:schemeClr val="accent1"/>
+          </a:effectRef>
+          <a:fontRef idx="minor">
+            <a:schemeClr val="lt1"/>
+          </a:fontRef>
+        </p:style>
+        <p:txBody>
+          <a:bodyPr rtlCol="0" anchor="ctr" wrap="none"/>
+          <a:lstStyle/>
+          <a:p>
+            <a:pPr algn="ctr"/>
+            <a:r>
+              <a:rPr sz="1200" b="0">
+                <a:solidFill>
+                  <a:srgbClr val="FFFFFF"/>
+                </a:solidFill>
+                <a:latin typeface="Calibri"/>
+              </a:rPr>
+              <a:t>10%</a:t>
+            </a:r>
+          </a:p>
+        </p:txBody>
+      </p:sp>
+      <p:sp>
+        <p:nvSpPr>
+          <p:cNvPr id="26" name="Rectangle 25"/>
+          <p:cNvSpPr/>
+          <p:nvPr/>
+        </p:nvSpPr>
+        <p:spPr>
+          <a:xfrm>
+            <a:off x="7086600" y="3090672"/>
+            <a:ext cx="640080" cy="420624"/>
+          </a:xfrm>
+          <a:prstGeom prst="rect">
+            <a:avLst/>
+          </a:prstGeom>
+          <a:solidFill>
+            <a:srgbClr val="0F2445"/>
+          </a:solidFill>
+          <a:ln w="6350">
+            <a:solidFill>
+              <a:srgbClr val="1E3A6E"/>
+            </a:solidFill>
+          </a:ln>
+          <a:effectLst/>
+        </p:spPr>
+        <p:style>
+          <a:lnRef idx="1">
+            <a:schemeClr val="accent1"/>
+          </a:lnRef>
+          <a:fillRef idx="3">
+            <a:schemeClr val="accent1"/>
+          </a:fillRef>
+          <a:effectRef idx="2">
+            <a:schemeClr val="accent1"/>
+          </a:effectRef>
+          <a:fontRef idx="minor">
+            <a:schemeClr val="lt1"/>
+          </a:fontRef>
+        </p:style>
+        <p:txBody>
+          <a:bodyPr rtlCol="0" anchor="ctr" wrap="none"/>
+          <a:lstStyle/>
+          <a:p>
+            <a:pPr algn="ctr"/>
+            <a:r>
+              <a:rPr sz="1200" b="0">
+                <a:solidFill>
+                  <a:srgbClr val="FFFFFF"/>
+                </a:solidFill>
+                <a:latin typeface="Calibri"/>
+              </a:rPr>
+              <a:t>15%</a:t>
+            </a:r>
+          </a:p>
+        </p:txBody>
+      </p:sp>
+      <p:sp>
+        <p:nvSpPr>
+          <p:cNvPr id="27" name="Rectangle 26"/>
+          <p:cNvSpPr/>
+          <p:nvPr/>
+        </p:nvSpPr>
+        <p:spPr>
+          <a:xfrm>
+            <a:off x="7726680" y="3090672"/>
+            <a:ext cx="594360" cy="420624"/>
+          </a:xfrm>
+          <a:prstGeom prst="rect">
+            <a:avLst/>
+          </a:prstGeom>
+          <a:solidFill>
+            <a:srgbClr val="0F2445"/>
+          </a:solidFill>
+          <a:ln w="6350">
+            <a:solidFill>
+              <a:srgbClr val="1E3A6E"/>
+            </a:solidFill>
+          </a:ln>
+          <a:effectLst/>
+        </p:spPr>
+        <p:style>
+          <a:lnRef idx="1">
+            <a:schemeClr val="accent1"/>
+          </a:lnRef>
+          <a:fillRef idx="3">
+            <a:schemeClr val="accent1"/>
+          </a:fillRef>
+          <a:effectRef idx="2">
+            <a:schemeClr val="accent1"/>
+          </a:effectRef>
+          <a:fontRef idx="minor">
+            <a:schemeClr val="lt1"/>
+          </a:fontRef>
+        </p:style>
+        <p:txBody>
+          <a:bodyPr rtlCol="0" anchor="ctr" wrap="none"/>
+          <a:lstStyle/>
+          <a:p>
+            <a:pPr algn="ctr"/>
+            <a:r>
+              <a:rPr sz="1200" b="0">
+                <a:solidFill>
+                  <a:srgbClr val="FFFFFF"/>
+                </a:solidFill>
+                <a:latin typeface="Calibri"/>
+              </a:rPr>
+              <a:t>5%</a:t>
+            </a:r>
+          </a:p>
+        </p:txBody>
+      </p:sp>
+      <p:sp>
+        <p:nvSpPr>
+          <p:cNvPr id="28" name="Rectangle 27"/>
+          <p:cNvSpPr/>
+          <p:nvPr/>
+        </p:nvSpPr>
+        <p:spPr>
+          <a:xfrm>
+            <a:off x="8321040" y="3090672"/>
+            <a:ext cx="868680" cy="420624"/>
+          </a:xfrm>
+          <a:prstGeom prst="rect">
+            <a:avLst/>
+          </a:prstGeom>
+          <a:solidFill>
+            <a:srgbClr val="0F2445"/>
+          </a:solidFill>
+          <a:ln w="6350">
+            <a:solidFill>
+              <a:srgbClr val="1E3A6E"/>
+            </a:solidFill>
+          </a:ln>
+          <a:effectLst/>
+        </p:spPr>
+        <p:style>
+          <a:lnRef idx="1">
+            <a:schemeClr val="accent1"/>
+          </a:lnRef>
+          <a:fillRef idx="3">
+            <a:schemeClr val="accent1"/>
+          </a:fillRef>
+          <a:effectRef idx="2">
+            <a:schemeClr val="accent1"/>
+          </a:effectRef>
+          <a:fontRef idx="minor">
+            <a:schemeClr val="lt1"/>
+          </a:fontRef>
+        </p:style>
+        <p:txBody>
+          <a:bodyPr rtlCol="0" anchor="ctr" wrap="none"/>
+          <a:lstStyle/>
+          <a:p>
+            <a:pPr algn="ctr"/>
+            <a:r>
+              <a:rPr sz="1200" b="0">
+                <a:solidFill>
+                  <a:srgbClr val="17B8C4"/>
+                </a:solidFill>
+                <a:latin typeface="Calibri"/>
+              </a:rPr>
+              <a:t>US$ 15k</a:t>
+            </a:r>
+          </a:p>
+        </p:txBody>
+      </p:sp>
+      <p:sp>
+        <p:nvSpPr>
+          <p:cNvPr id="29" name="Rectangle 28"/>
+          <p:cNvSpPr/>
+          <p:nvPr/>
+        </p:nvSpPr>
+        <p:spPr>
+          <a:xfrm>
+            <a:off x="9189720" y="3090672"/>
+            <a:ext cx="777240" cy="420624"/>
+          </a:xfrm>
+          <a:prstGeom prst="rect">
+            <a:avLst/>
+          </a:prstGeom>
+          <a:solidFill>
+            <a:srgbClr val="0F2445"/>
+          </a:solidFill>
+          <a:ln w="6350">
+            <a:solidFill>
+              <a:srgbClr val="1E3A6E"/>
+            </a:solidFill>
+          </a:ln>
+          <a:effectLst/>
+        </p:spPr>
+        <p:style>
+          <a:lnRef idx="1">
+            <a:schemeClr val="accent1"/>
+          </a:lnRef>
+          <a:fillRef idx="3">
+            <a:schemeClr val="accent1"/>
+          </a:fillRef>
+          <a:effectRef idx="2">
+            <a:schemeClr val="accent1"/>
+          </a:effectRef>
+          <a:fontRef idx="minor">
+            <a:schemeClr val="lt1"/>
+          </a:fontRef>
+        </p:style>
+        <p:txBody>
+          <a:bodyPr rtlCol="0" anchor="ctr" wrap="none"/>
+          <a:lstStyle/>
+          <a:p>
+            <a:pPr algn="ctr"/>
+            <a:r>
+              <a:rPr sz="1200" b="0">
+                <a:solidFill>
+                  <a:srgbClr val="4CE8A8"/>
+                </a:solidFill>
+                <a:latin typeface="Calibri"/>
+              </a:rPr>
+              <a:t>15%</a:t>
+            </a:r>
+          </a:p>
+        </p:txBody>
+      </p:sp>
+      <p:sp>
+        <p:nvSpPr>
+          <p:cNvPr id="30" name="Rectangle 29"/>
+          <p:cNvSpPr/>
+          <p:nvPr/>
+        </p:nvSpPr>
+        <p:spPr>
+          <a:xfrm>
+            <a:off x="4434840" y="3511296"/>
+            <a:ext cx="2011680" cy="420624"/>
+          </a:xfrm>
+          <a:prstGeom prst="rect">
+            <a:avLst/>
+          </a:prstGeom>
+          <a:solidFill>
+            <a:srgbClr val="142A50"/>
+          </a:solidFill>
+          <a:ln w="6350">
+            <a:solidFill>
+              <a:srgbClr val="1E3A6E"/>
+            </a:solidFill>
+          </a:ln>
+          <a:effectLst/>
+        </p:spPr>
+        <p:style>
+          <a:lnRef idx="1">
+            <a:schemeClr val="accent1"/>
+          </a:lnRef>
+          <a:fillRef idx="3">
+            <a:schemeClr val="accent1"/>
+          </a:fillRef>
+          <a:effectRef idx="2">
+            <a:schemeClr val="accent1"/>
+          </a:effectRef>
+          <a:fontRef idx="minor">
+            <a:schemeClr val="lt1"/>
+          </a:fontRef>
+        </p:style>
+        <p:txBody>
+          <a:bodyPr rtlCol="0" anchor="ctr" wrap="none"/>
+          <a:lstStyle/>
+          <a:p>
+            <a:pPr algn="ctr"/>
+            <a:r>
+              <a:rPr sz="1200" b="0">
+                <a:solidFill>
+                  <a:srgbClr val="FFFFFF"/>
+                </a:solidFill>
+                <a:latin typeface="Calibri"/>
+              </a:rPr>
+              <a:t>AV4040  Fundos</a:t>
+            </a:r>
+          </a:p>
+        </p:txBody>
+      </p:sp>
+      <p:sp>
+        <p:nvSpPr>
+          <p:cNvPr id="31" name="Rectangle 30"/>
+          <p:cNvSpPr/>
+          <p:nvPr/>
+        </p:nvSpPr>
+        <p:spPr>
+          <a:xfrm>
+            <a:off x="6446520" y="3511296"/>
+            <a:ext cx="640080" cy="420624"/>
+          </a:xfrm>
+          <a:prstGeom prst="rect">
+            <a:avLst/>
+          </a:prstGeom>
+          <a:solidFill>
+            <a:srgbClr val="142A50"/>
+          </a:solidFill>
+          <a:ln w="6350">
+            <a:solidFill>
+              <a:srgbClr val="1E3A6E"/>
+            </a:solidFill>
+          </a:ln>
+          <a:effectLst/>
+        </p:spPr>
+        <p:style>
+          <a:lnRef idx="1">
+            <a:schemeClr val="accent1"/>
+          </a:lnRef>
+          <a:fillRef idx="3">
+            <a:schemeClr val="accent1"/>
+          </a:fillRef>
+          <a:effectRef idx="2">
+            <a:schemeClr val="accent1"/>
+          </a:effectRef>
+          <a:fontRef idx="minor">
+            <a:schemeClr val="lt1"/>
+          </a:fontRef>
+        </p:style>
+        <p:txBody>
+          <a:bodyPr rtlCol="0" anchor="ctr" wrap="none"/>
+          <a:lstStyle/>
+          <a:p>
+            <a:pPr algn="ctr"/>
+            <a:r>
+              <a:rPr sz="1200" b="0">
+                <a:solidFill>
+                  <a:srgbClr val="FFFFFF"/>
+                </a:solidFill>
+                <a:latin typeface="Calibri"/>
+              </a:rPr>
+              <a:t>18%</a:t>
+            </a:r>
+          </a:p>
+        </p:txBody>
+      </p:sp>
+      <p:sp>
+        <p:nvSpPr>
+          <p:cNvPr id="32" name="Rectangle 31"/>
+          <p:cNvSpPr/>
+          <p:nvPr/>
+        </p:nvSpPr>
+        <p:spPr>
+          <a:xfrm>
+            <a:off x="7086600" y="3511296"/>
+            <a:ext cx="640080" cy="420624"/>
+          </a:xfrm>
+          <a:prstGeom prst="rect">
+            <a:avLst/>
+          </a:prstGeom>
+          <a:solidFill>
+            <a:srgbClr val="142A50"/>
+          </a:solidFill>
+          <a:ln w="6350">
+            <a:solidFill>
+              <a:srgbClr val="1E3A6E"/>
+            </a:solidFill>
+          </a:ln>
+          <a:effectLst/>
+        </p:spPr>
+        <p:style>
+          <a:lnRef idx="1">
+            <a:schemeClr val="accent1"/>
+          </a:lnRef>
+          <a:fillRef idx="3">
+            <a:schemeClr val="accent1"/>
+          </a:fillRef>
+          <a:effectRef idx="2">
+            <a:schemeClr val="accent1"/>
+          </a:effectRef>
+          <a:fontRef idx="minor">
+            <a:schemeClr val="lt1"/>
+          </a:fontRef>
+        </p:style>
+        <p:txBody>
+          <a:bodyPr rtlCol="0" anchor="ctr" wrap="none"/>
+          <a:lstStyle/>
+          <a:p>
+            <a:pPr algn="ctr"/>
+            <a:r>
+              <a:rPr sz="1200" b="0">
+                <a:solidFill>
+                  <a:srgbClr val="FFFFFF"/>
+                </a:solidFill>
+                <a:latin typeface="Calibri"/>
+              </a:rPr>
+              <a:t>25%</a:t>
+            </a:r>
+          </a:p>
+        </p:txBody>
+      </p:sp>
+      <p:sp>
+        <p:nvSpPr>
+          <p:cNvPr id="33" name="Rectangle 32"/>
+          <p:cNvSpPr/>
+          <p:nvPr/>
+        </p:nvSpPr>
+        <p:spPr>
+          <a:xfrm>
+            <a:off x="7726680" y="3511296"/>
+            <a:ext cx="594360" cy="420624"/>
+          </a:xfrm>
+          <a:prstGeom prst="rect">
+            <a:avLst/>
+          </a:prstGeom>
+          <a:solidFill>
+            <a:srgbClr val="142A50"/>
+          </a:solidFill>
+          <a:ln w="6350">
+            <a:solidFill>
+              <a:srgbClr val="1E3A6E"/>
+            </a:solidFill>
+          </a:ln>
+          <a:effectLst/>
+        </p:spPr>
+        <p:style>
+          <a:lnRef idx="1">
+            <a:schemeClr val="accent1"/>
+          </a:lnRef>
+          <a:fillRef idx="3">
+            <a:schemeClr val="accent1"/>
+          </a:fillRef>
+          <a:effectRef idx="2">
+            <a:schemeClr val="accent1"/>
+          </a:effectRef>
+          <a:fontRef idx="minor">
+            <a:schemeClr val="lt1"/>
+          </a:fontRef>
+        </p:style>
+        <p:txBody>
+          <a:bodyPr rtlCol="0" anchor="ctr" wrap="none"/>
+          <a:lstStyle/>
+          <a:p>
+            <a:pPr algn="ctr"/>
+            <a:r>
+              <a:rPr sz="1200" b="0">
+                <a:solidFill>
+                  <a:srgbClr val="FFFFFF"/>
+                </a:solidFill>
+                <a:latin typeface="Calibri"/>
+              </a:rPr>
+              <a:t>7%</a:t>
+            </a:r>
+          </a:p>
+        </p:txBody>
+      </p:sp>
+      <p:sp>
+        <p:nvSpPr>
+          <p:cNvPr id="34" name="Rectangle 33"/>
+          <p:cNvSpPr/>
+          <p:nvPr/>
+        </p:nvSpPr>
+        <p:spPr>
+          <a:xfrm>
+            <a:off x="8321040" y="3511296"/>
+            <a:ext cx="868680" cy="420624"/>
+          </a:xfrm>
+          <a:prstGeom prst="rect">
+            <a:avLst/>
+          </a:prstGeom>
+          <a:solidFill>
+            <a:srgbClr val="142A50"/>
+          </a:solidFill>
+          <a:ln w="6350">
+            <a:solidFill>
+              <a:srgbClr val="1E3A6E"/>
+            </a:solidFill>
+          </a:ln>
+          <a:effectLst/>
+        </p:spPr>
+        <p:style>
+          <a:lnRef idx="1">
+            <a:schemeClr val="accent1"/>
+          </a:lnRef>
+          <a:fillRef idx="3">
+            <a:schemeClr val="accent1"/>
+          </a:fillRef>
+          <a:effectRef idx="2">
+            <a:schemeClr val="accent1"/>
+          </a:effectRef>
+          <a:fontRef idx="minor">
+            <a:schemeClr val="lt1"/>
+          </a:fontRef>
+        </p:style>
+        <p:txBody>
+          <a:bodyPr rtlCol="0" anchor="ctr" wrap="none"/>
+          <a:lstStyle/>
+          <a:p>
+            <a:pPr algn="ctr"/>
+            <a:r>
+              <a:rPr sz="1200" b="0">
+                <a:solidFill>
+                  <a:srgbClr val="17B8C4"/>
+                </a:solidFill>
+                <a:latin typeface="Calibri"/>
+              </a:rPr>
+              <a:t>US$ 21k</a:t>
+            </a:r>
+          </a:p>
+        </p:txBody>
+      </p:sp>
+      <p:sp>
+        <p:nvSpPr>
+          <p:cNvPr id="35" name="Rectangle 34"/>
+          <p:cNvSpPr/>
+          <p:nvPr/>
+        </p:nvSpPr>
+        <p:spPr>
+          <a:xfrm>
+            <a:off x="9189720" y="3511296"/>
+            <a:ext cx="777240" cy="420624"/>
+          </a:xfrm>
+          <a:prstGeom prst="rect">
+            <a:avLst/>
+          </a:prstGeom>
+          <a:solidFill>
+            <a:srgbClr val="142A50"/>
+          </a:solidFill>
+          <a:ln w="6350">
+            <a:solidFill>
+              <a:srgbClr val="1E3A6E"/>
+            </a:solidFill>
+          </a:ln>
+          <a:effectLst/>
+        </p:spPr>
+        <p:style>
+          <a:lnRef idx="1">
+            <a:schemeClr val="accent1"/>
+          </a:lnRef>
+          <a:fillRef idx="3">
+            <a:schemeClr val="accent1"/>
+          </a:fillRef>
+          <a:effectRef idx="2">
+            <a:schemeClr val="accent1"/>
+          </a:effectRef>
+          <a:fontRef idx="minor">
+            <a:schemeClr val="lt1"/>
+          </a:fontRef>
+        </p:style>
+        <p:txBody>
+          <a:bodyPr rtlCol="0" anchor="ctr" wrap="none"/>
+          <a:lstStyle/>
+          <a:p>
+            <a:pPr algn="ctr"/>
+            <a:r>
+              <a:rPr sz="1200" b="0">
+                <a:solidFill>
+                  <a:srgbClr val="4CE8A8"/>
+                </a:solidFill>
+                <a:latin typeface="Calibri"/>
+              </a:rPr>
+              <a:t>25%</a:t>
+            </a:r>
+          </a:p>
+        </p:txBody>
+      </p:sp>
+      <p:sp>
+        <p:nvSpPr>
+          <p:cNvPr id="36" name="Rectangle 35"/>
+          <p:cNvSpPr/>
+          <p:nvPr/>
+        </p:nvSpPr>
+        <p:spPr>
+          <a:xfrm>
+            <a:off x="4434840" y="3931920"/>
+            <a:ext cx="2011680" cy="420624"/>
+          </a:xfrm>
+          <a:prstGeom prst="rect">
+            <a:avLst/>
+          </a:prstGeom>
+          <a:solidFill>
+            <a:srgbClr val="0F2445"/>
+          </a:solidFill>
+          <a:ln w="6350">
+            <a:solidFill>
+              <a:srgbClr val="1E3A6E"/>
+            </a:solidFill>
+          </a:ln>
+          <a:effectLst/>
+        </p:spPr>
+        <p:style>
+          <a:lnRef idx="1">
+            <a:schemeClr val="accent1"/>
+          </a:lnRef>
+          <a:fillRef idx="3">
+            <a:schemeClr val="accent1"/>
+          </a:fillRef>
+          <a:effectRef idx="2">
+            <a:schemeClr val="accent1"/>
+          </a:effectRef>
+          <a:fontRef idx="minor">
+            <a:schemeClr val="lt1"/>
+          </a:fontRef>
+        </p:style>
+        <p:txBody>
+          <a:bodyPr rtlCol="0" anchor="ctr" wrap="none"/>
+          <a:lstStyle/>
+          <a:p>
+            <a:pPr algn="ctr"/>
+            <a:r>
+              <a:rPr sz="1200" b="0">
+                <a:solidFill>
+                  <a:srgbClr val="FFFFFF"/>
+                </a:solidFill>
+                <a:latin typeface="Calibri"/>
+              </a:rPr>
+              <a:t>AV5050  Alternat.</a:t>
+            </a:r>
+          </a:p>
+        </p:txBody>
+      </p:sp>
+      <p:sp>
+        <p:nvSpPr>
+          <p:cNvPr id="37" name="Rectangle 36"/>
+          <p:cNvSpPr/>
+          <p:nvPr/>
+        </p:nvSpPr>
+        <p:spPr>
+          <a:xfrm>
+            <a:off x="6446520" y="3931920"/>
+            <a:ext cx="640080" cy="420624"/>
+          </a:xfrm>
+          <a:prstGeom prst="rect">
+            <a:avLst/>
+          </a:prstGeom>
+          <a:solidFill>
+            <a:srgbClr val="0F2445"/>
+          </a:solidFill>
+          <a:ln w="6350">
+            <a:solidFill>
+              <a:srgbClr val="1E3A6E"/>
+            </a:solidFill>
+          </a:ln>
+          <a:effectLst/>
+        </p:spPr>
+        <p:style>
+          <a:lnRef idx="1">
+            <a:schemeClr val="accent1"/>
+          </a:lnRef>
+          <a:fillRef idx="3">
+            <a:schemeClr val="accent1"/>
+          </a:fillRef>
+          <a:effectRef idx="2">
+            <a:schemeClr val="accent1"/>
+          </a:effectRef>
+          <a:fontRef idx="minor">
+            <a:schemeClr val="lt1"/>
+          </a:fontRef>
+        </p:style>
+        <p:txBody>
+          <a:bodyPr rtlCol="0" anchor="ctr" wrap="none"/>
+          <a:lstStyle/>
+          <a:p>
+            <a:pPr algn="ctr"/>
+            <a:r>
+              <a:rPr sz="1200" b="0">
+                <a:solidFill>
+                  <a:srgbClr val="FFFFFF"/>
+                </a:solidFill>
+                <a:latin typeface="Calibri"/>
+              </a:rPr>
+              <a:t>4%</a:t>
+            </a:r>
+          </a:p>
+        </p:txBody>
+      </p:sp>
+      <p:sp>
+        <p:nvSpPr>
+          <p:cNvPr id="38" name="Rectangle 37"/>
+          <p:cNvSpPr/>
+          <p:nvPr/>
+        </p:nvSpPr>
+        <p:spPr>
+          <a:xfrm>
+            <a:off x="7086600" y="3931920"/>
+            <a:ext cx="640080" cy="420624"/>
+          </a:xfrm>
+          <a:prstGeom prst="rect">
+            <a:avLst/>
+          </a:prstGeom>
+          <a:solidFill>
+            <a:srgbClr val="0F2445"/>
+          </a:solidFill>
+          <a:ln w="6350">
+            <a:solidFill>
+              <a:srgbClr val="1E3A6E"/>
+            </a:solidFill>
+          </a:ln>
+          <a:effectLst/>
+        </p:spPr>
+        <p:style>
+          <a:lnRef idx="1">
+            <a:schemeClr val="accent1"/>
+          </a:lnRef>
+          <a:fillRef idx="3">
+            <a:schemeClr val="accent1"/>
+          </a:fillRef>
+          <a:effectRef idx="2">
+            <a:schemeClr val="accent1"/>
+          </a:effectRef>
+          <a:fontRef idx="minor">
+            <a:schemeClr val="lt1"/>
+          </a:fontRef>
+        </p:style>
+        <p:txBody>
+          <a:bodyPr rtlCol="0" anchor="ctr" wrap="none"/>
+          <a:lstStyle/>
+          <a:p>
+            <a:pPr algn="ctr"/>
+            <a:r>
+              <a:rPr sz="1200" b="0">
+                <a:solidFill>
+                  <a:srgbClr val="FFFFFF"/>
+                </a:solidFill>
+                <a:latin typeface="Calibri"/>
+              </a:rPr>
+              <a:t>10%</a:t>
+            </a:r>
+          </a:p>
+        </p:txBody>
+      </p:sp>
+      <p:sp>
+        <p:nvSpPr>
+          <p:cNvPr id="39" name="Rectangle 38"/>
+          <p:cNvSpPr/>
+          <p:nvPr/>
+        </p:nvSpPr>
+        <p:spPr>
+          <a:xfrm>
+            <a:off x="7726680" y="3931920"/>
+            <a:ext cx="594360" cy="420624"/>
+          </a:xfrm>
+          <a:prstGeom prst="rect">
+            <a:avLst/>
+          </a:prstGeom>
+          <a:solidFill>
+            <a:srgbClr val="0F2445"/>
+          </a:solidFill>
+          <a:ln w="6350">
+            <a:solidFill>
+              <a:srgbClr val="1E3A6E"/>
+            </a:solidFill>
+          </a:ln>
+          <a:effectLst/>
+        </p:spPr>
+        <p:style>
+          <a:lnRef idx="1">
+            <a:schemeClr val="accent1"/>
+          </a:lnRef>
+          <a:fillRef idx="3">
+            <a:schemeClr val="accent1"/>
+          </a:fillRef>
+          <a:effectRef idx="2">
+            <a:schemeClr val="accent1"/>
+          </a:effectRef>
+          <a:fontRef idx="minor">
+            <a:schemeClr val="lt1"/>
+          </a:fontRef>
+        </p:style>
+        <p:txBody>
+          <a:bodyPr rtlCol="0" anchor="ctr" wrap="none"/>
+          <a:lstStyle/>
+          <a:p>
+            <a:pPr algn="ctr"/>
+            <a:r>
+              <a:rPr sz="1200" b="0">
+                <a:solidFill>
+                  <a:srgbClr val="FFFFFF"/>
+                </a:solidFill>
+                <a:latin typeface="Calibri"/>
+              </a:rPr>
+              <a:t>6%</a:t>
+            </a:r>
+          </a:p>
+        </p:txBody>
+      </p:sp>
+      <p:sp>
+        <p:nvSpPr>
+          <p:cNvPr id="40" name="Rectangle 39"/>
+          <p:cNvSpPr/>
+          <p:nvPr/>
+        </p:nvSpPr>
+        <p:spPr>
+          <a:xfrm>
+            <a:off x="8321040" y="3931920"/>
+            <a:ext cx="868680" cy="420624"/>
+          </a:xfrm>
+          <a:prstGeom prst="rect">
+            <a:avLst/>
+          </a:prstGeom>
+          <a:solidFill>
+            <a:srgbClr val="0F2445"/>
+          </a:solidFill>
+          <a:ln w="6350">
+            <a:solidFill>
+              <a:srgbClr val="1E3A6E"/>
+            </a:solidFill>
+          </a:ln>
+          <a:effectLst/>
+        </p:spPr>
+        <p:style>
+          <a:lnRef idx="1">
+            <a:schemeClr val="accent1"/>
+          </a:lnRef>
+          <a:fillRef idx="3">
+            <a:schemeClr val="accent1"/>
+          </a:fillRef>
+          <a:effectRef idx="2">
+            <a:schemeClr val="accent1"/>
+          </a:effectRef>
+          <a:fontRef idx="minor">
+            <a:schemeClr val="lt1"/>
+          </a:fontRef>
+        </p:style>
+        <p:txBody>
+          <a:bodyPr rtlCol="0" anchor="ctr" wrap="none"/>
+          <a:lstStyle/>
+          <a:p>
+            <a:pPr algn="ctr"/>
+            <a:r>
+              <a:rPr sz="1200" b="0">
+                <a:solidFill>
+                  <a:srgbClr val="17B8C4"/>
+                </a:solidFill>
+                <a:latin typeface="Calibri"/>
+              </a:rPr>
+              <a:t>US$ 18k</a:t>
+            </a:r>
+          </a:p>
+        </p:txBody>
+      </p:sp>
+      <p:sp>
+        <p:nvSpPr>
+          <p:cNvPr id="41" name="Rectangle 40"/>
+          <p:cNvSpPr/>
+          <p:nvPr/>
+        </p:nvSpPr>
+        <p:spPr>
+          <a:xfrm>
+            <a:off x="9189720" y="3931920"/>
+            <a:ext cx="777240" cy="420624"/>
+          </a:xfrm>
+          <a:prstGeom prst="rect">
+            <a:avLst/>
+          </a:prstGeom>
+          <a:solidFill>
+            <a:srgbClr val="0F2445"/>
+          </a:solidFill>
+          <a:ln w="6350">
+            <a:solidFill>
+              <a:srgbClr val="1E3A6E"/>
+            </a:solidFill>
+          </a:ln>
+          <a:effectLst/>
+        </p:spPr>
+        <p:style>
+          <a:lnRef idx="1">
+            <a:schemeClr val="accent1"/>
+          </a:lnRef>
+          <a:fillRef idx="3">
+            <a:schemeClr val="accent1"/>
+          </a:fillRef>
+          <a:effectRef idx="2">
+            <a:schemeClr val="accent1"/>
+          </a:effectRef>
+          <a:fontRef idx="minor">
+            <a:schemeClr val="lt1"/>
+          </a:fontRef>
+        </p:style>
+        <p:txBody>
+          <a:bodyPr rtlCol="0" anchor="ctr" wrap="none"/>
+          <a:lstStyle/>
+          <a:p>
+            <a:pPr algn="ctr"/>
+            <a:r>
+              <a:rPr sz="1200" b="0">
+                <a:solidFill>
+                  <a:srgbClr val="4CE8A8"/>
+                </a:solidFill>
+                <a:latin typeface="Calibri"/>
+              </a:rPr>
+              <a:t>10%</a:t>
+            </a:r>
+          </a:p>
+        </p:txBody>
+      </p:sp>
+      <p:sp>
+        <p:nvSpPr>
+          <p:cNvPr id="42" name="Rectangle 41"/>
+          <p:cNvSpPr/>
+          <p:nvPr/>
+        </p:nvSpPr>
+        <p:spPr>
+          <a:xfrm>
+            <a:off x="4434840" y="4352544"/>
+            <a:ext cx="2011680" cy="420624"/>
+          </a:xfrm>
+          <a:prstGeom prst="rect">
+            <a:avLst/>
+          </a:prstGeom>
+          <a:solidFill>
+            <a:srgbClr val="142A50"/>
+          </a:solidFill>
+          <a:ln w="6350">
+            <a:solidFill>
+              <a:srgbClr val="1E3A6E"/>
+            </a:solidFill>
+          </a:ln>
+          <a:effectLst/>
+        </p:spPr>
+        <p:style>
+          <a:lnRef idx="1">
+            <a:schemeClr val="accent1"/>
+          </a:lnRef>
+          <a:fillRef idx="3">
+            <a:schemeClr val="accent1"/>
+          </a:fillRef>
+          <a:effectRef idx="2">
+            <a:schemeClr val="accent1"/>
+          </a:effectRef>
+          <a:fontRef idx="minor">
+            <a:schemeClr val="lt1"/>
+          </a:fontRef>
+        </p:style>
+        <p:txBody>
+          <a:bodyPr rtlCol="0" anchor="ctr" wrap="none"/>
+          <a:lstStyle/>
+          <a:p>
+            <a:pPr algn="ctr"/>
+            <a:r>
+              <a:rPr sz="1200" b="0">
+                <a:solidFill>
+                  <a:srgbClr val="FFFFFF"/>
+                </a:solidFill>
+                <a:latin typeface="Calibri"/>
+              </a:rPr>
+              <a:t>Caixa</a:t>
+            </a:r>
+          </a:p>
+        </p:txBody>
+      </p:sp>
+      <p:sp>
+        <p:nvSpPr>
+          <p:cNvPr id="43" name="Rectangle 42"/>
+          <p:cNvSpPr/>
+          <p:nvPr/>
+        </p:nvSpPr>
+        <p:spPr>
+          <a:xfrm>
+            <a:off x="6446520" y="4352544"/>
+            <a:ext cx="640080" cy="420624"/>
+          </a:xfrm>
+          <a:prstGeom prst="rect">
+            <a:avLst/>
+          </a:prstGeom>
+          <a:solidFill>
+            <a:srgbClr val="142A50"/>
+          </a:solidFill>
+          <a:ln w="6350">
+            <a:solidFill>
+              <a:srgbClr val="1E3A6E"/>
+            </a:solidFill>
+          </a:ln>
+          <a:effectLst/>
+        </p:spPr>
+        <p:style>
+          <a:lnRef idx="1">
+            <a:schemeClr val="accent1"/>
+          </a:lnRef>
+          <a:fillRef idx="3">
+            <a:schemeClr val="accent1"/>
+          </a:fillRef>
+          <a:effectRef idx="2">
+            <a:schemeClr val="accent1"/>
+          </a:effectRef>
+          <a:fontRef idx="minor">
+            <a:schemeClr val="lt1"/>
+          </a:fontRef>
+        </p:style>
+        <p:txBody>
+          <a:bodyPr rtlCol="0" anchor="ctr" wrap="none"/>
+          <a:lstStyle/>
+          <a:p>
+            <a:pPr algn="ctr"/>
+            <a:r>
+              <a:rPr sz="1200" b="0">
+                <a:solidFill>
+                  <a:srgbClr val="FFFFFF"/>
+                </a:solidFill>
+                <a:latin typeface="Calibri"/>
+              </a:rPr>
+              <a:t>US$300k</a:t>
+            </a:r>
+          </a:p>
+        </p:txBody>
+      </p:sp>
+      <p:sp>
+        <p:nvSpPr>
+          <p:cNvPr id="44" name="Rectangle 43"/>
+          <p:cNvSpPr/>
+          <p:nvPr/>
+        </p:nvSpPr>
+        <p:spPr>
+          <a:xfrm>
+            <a:off x="7086600" y="4352544"/>
+            <a:ext cx="640080" cy="420624"/>
+          </a:xfrm>
+          <a:prstGeom prst="rect">
+            <a:avLst/>
+          </a:prstGeom>
+          <a:solidFill>
+            <a:srgbClr val="142A50"/>
+          </a:solidFill>
+          <a:ln w="6350">
+            <a:solidFill>
+              <a:srgbClr val="1E3A6E"/>
+            </a:solidFill>
+          </a:ln>
+          <a:effectLst/>
+        </p:spPr>
+        <p:style>
+          <a:lnRef idx="1">
+            <a:schemeClr val="accent1"/>
+          </a:lnRef>
+          <a:fillRef idx="3">
+            <a:schemeClr val="accent1"/>
+          </a:fillRef>
+          <a:effectRef idx="2">
+            <a:schemeClr val="accent1"/>
+          </a:effectRef>
+          <a:fontRef idx="minor">
+            <a:schemeClr val="lt1"/>
+          </a:fontRef>
+        </p:style>
+        <p:txBody>
+          <a:bodyPr rtlCol="0" anchor="ctr" wrap="none"/>
+          <a:lstStyle/>
+          <a:p>
+            <a:pPr algn="ctr"/>
+            <a:r>
+              <a:rPr sz="1200" b="0">
+                <a:solidFill>
+                  <a:srgbClr val="FFFFFF"/>
+                </a:solidFill>
+                <a:latin typeface="Calibri"/>
+              </a:rPr>
+              <a:t>–</a:t>
+            </a:r>
+          </a:p>
+        </p:txBody>
+      </p:sp>
+      <p:sp>
+        <p:nvSpPr>
+          <p:cNvPr id="45" name="Rectangle 44"/>
+          <p:cNvSpPr/>
+          <p:nvPr/>
+        </p:nvSpPr>
+        <p:spPr>
+          <a:xfrm>
+            <a:off x="7726680" y="4352544"/>
+            <a:ext cx="594360" cy="420624"/>
+          </a:xfrm>
+          <a:prstGeom prst="rect">
+            <a:avLst/>
+          </a:prstGeom>
+          <a:solidFill>
+            <a:srgbClr val="142A50"/>
+          </a:solidFill>
+          <a:ln w="6350">
+            <a:solidFill>
+              <a:srgbClr val="1E3A6E"/>
+            </a:solidFill>
+          </a:ln>
+          <a:effectLst/>
+        </p:spPr>
+        <p:style>
+          <a:lnRef idx="1">
+            <a:schemeClr val="accent1"/>
+          </a:lnRef>
+          <a:fillRef idx="3">
+            <a:schemeClr val="accent1"/>
+          </a:fillRef>
+          <a:effectRef idx="2">
+            <a:schemeClr val="accent1"/>
+          </a:effectRef>
+          <a:fontRef idx="minor">
+            <a:schemeClr val="lt1"/>
+          </a:fontRef>
+        </p:style>
+        <p:txBody>
+          <a:bodyPr rtlCol="0" anchor="ctr" wrap="none"/>
+          <a:lstStyle/>
+          <a:p>
+            <a:pPr algn="ctr"/>
+            <a:r>
+              <a:rPr sz="1200" b="0">
+                <a:solidFill>
+                  <a:srgbClr val="FFFFFF"/>
+                </a:solidFill>
+                <a:latin typeface="Calibri"/>
+              </a:rPr>
+              <a:t>–</a:t>
+            </a:r>
+          </a:p>
+        </p:txBody>
+      </p:sp>
+      <p:sp>
+        <p:nvSpPr>
+          <p:cNvPr id="46" name="Rectangle 45"/>
+          <p:cNvSpPr/>
+          <p:nvPr/>
+        </p:nvSpPr>
+        <p:spPr>
+          <a:xfrm>
+            <a:off x="8321040" y="4352544"/>
+            <a:ext cx="868680" cy="420624"/>
+          </a:xfrm>
+          <a:prstGeom prst="rect">
+            <a:avLst/>
+          </a:prstGeom>
+          <a:solidFill>
+            <a:srgbClr val="142A50"/>
+          </a:solidFill>
+          <a:ln w="6350">
+            <a:solidFill>
+              <a:srgbClr val="1E3A6E"/>
+            </a:solidFill>
+          </a:ln>
+          <a:effectLst/>
+        </p:spPr>
+        <p:style>
+          <a:lnRef idx="1">
+            <a:schemeClr val="accent1"/>
+          </a:lnRef>
+          <a:fillRef idx="3">
+            <a:schemeClr val="accent1"/>
+          </a:fillRef>
+          <a:effectRef idx="2">
+            <a:schemeClr val="accent1"/>
+          </a:effectRef>
+          <a:fontRef idx="minor">
+            <a:schemeClr val="lt1"/>
+          </a:fontRef>
+        </p:style>
+        <p:txBody>
+          <a:bodyPr rtlCol="0" anchor="ctr" wrap="none"/>
+          <a:lstStyle/>
+          <a:p>
+            <a:pPr algn="ctr"/>
+            <a:r>
+              <a:rPr sz="1200" b="0">
+                <a:solidFill>
+                  <a:srgbClr val="17B8C4"/>
+                </a:solidFill>
+                <a:latin typeface="Calibri"/>
+              </a:rPr>
+              <a:t>–US$90k</a:t>
+            </a:r>
+          </a:p>
+        </p:txBody>
+      </p:sp>
+      <p:sp>
+        <p:nvSpPr>
+          <p:cNvPr id="47" name="Rectangle 46"/>
+          <p:cNvSpPr/>
+          <p:nvPr/>
+        </p:nvSpPr>
+        <p:spPr>
+          <a:xfrm>
+            <a:off x="9189720" y="4352544"/>
+            <a:ext cx="777240" cy="420624"/>
+          </a:xfrm>
+          <a:prstGeom prst="rect">
+            <a:avLst/>
+          </a:prstGeom>
+          <a:solidFill>
+            <a:srgbClr val="142A50"/>
+          </a:solidFill>
+          <a:ln w="6350">
+            <a:solidFill>
+              <a:srgbClr val="1E3A6E"/>
+            </a:solidFill>
+          </a:ln>
+          <a:effectLst/>
+        </p:spPr>
+        <p:style>
+          <a:lnRef idx="1">
+            <a:schemeClr val="accent1"/>
+          </a:lnRef>
+          <a:fillRef idx="3">
+            <a:schemeClr val="accent1"/>
+          </a:fillRef>
+          <a:effectRef idx="2">
+            <a:schemeClr val="accent1"/>
+          </a:effectRef>
+          <a:fontRef idx="minor">
+            <a:schemeClr val="lt1"/>
+          </a:fontRef>
+        </p:style>
+        <p:txBody>
+          <a:bodyPr rtlCol="0" anchor="ctr" wrap="none"/>
+          <a:lstStyle/>
+          <a:p>
+            <a:pPr algn="ctr"/>
+            <a:r>
+              <a:rPr sz="1200" b="0">
+                <a:solidFill>
+                  <a:srgbClr val="4CE8A8"/>
+                </a:solidFill>
+                <a:latin typeface="Calibri"/>
+              </a:rPr>
+              <a:t>US$210k</a:t>
+            </a:r>
+          </a:p>
+        </p:txBody>
+      </p:sp>
+      <p:sp>
+        <p:nvSpPr>
+          <p:cNvPr id="48" name="TextBox 47"/>
           <p:cNvSpPr txBox="1"/>
           <p:nvPr/>
         </p:nvSpPr>
         <p:spPr>
           <a:xfrm>
-            <a:off x="10698480" y="5852160"/>
-            <a:ext cx="960120" cy="365760"/>
+            <a:off x="4434840" y="4846320"/>
+            <a:ext cx="7680960" cy="365760"/>
           </a:xfrm>
           <a:prstGeom prst="rect">
             <a:avLst/>
@@ -8598,27 +10579,31 @@
           <a:noFill/>
         </p:spPr>
         <p:txBody>
-          <a:bodyPr wrap="none">
+          <a:bodyPr wrap="square" anchor="t">
             <a:spAutoFit/>
           </a:bodyPr>
           <a:lstStyle/>
           <a:p>
-            <a:pPr algn="ctr"/>
-            <a:r>
-              <a:rPr sz="1000">
-                <a:solidFill>
-                  <a:srgbClr val="C9D6E6"/>
-                </a:solidFill>
-                <a:latin typeface="Calibri"/>
-              </a:rPr>
-              <a:t>Alt.</a:t>
-            </a:r>
-          </a:p>
-        </p:txBody>
-      </p:sp>
-      <p:sp>
-        <p:nvSpPr>
-          <p:cNvPr id="18" name="TextBox 17"/>
+            <a:pPr algn="l">
+              <a:spcAft>
+                <a:spcPts val="600"/>
+              </a:spcAft>
+            </a:pPr>
+            <a:r>
+              <a:rPr sz="1000" b="0" i="1">
+                <a:solidFill>
+                  <a:srgbClr val="6B7280"/>
+                </a:solidFill>
+                <a:latin typeface="Calibri"/>
+              </a:rPr>
+              <a:t>Exemplo ilustrativo — cliente perfil moderado, aporte de US$ 100k + caixa existente de US$ 200k</a:t>
+            </a:r>
+          </a:p>
+        </p:txBody>
+      </p:sp>
+      <p:sp>
+        <p:nvSpPr>
+          <p:cNvPr id="49" name="TextBox 48"/>
           <p:cNvSpPr txBox="1"/>
           <p:nvPr/>
         </p:nvSpPr>

</xml_diff>